<commit_message>
Final editing pass: clean stale refs, update dep map, rebuild PDFs
- Replace EXAM_TM10_POST with EXAM_TM10_SUPPLEMENTAL across 6 files
- Add ANNUAL_TRAINING_CALENDAR_FY27.html and INSTRUCTOR_OVERVIEW to dep map
- Update audit.py to expect supplemental (not post) for TM-10
- Update DEPENDENCY_MAP date to 16 March 2026
- Full curriculum audit: Commander's Guide, training schedule, ATIS packet
- Regenerate all PDFs; rebuild PPTX decks
- 331 files touched; audit passes clean (all 7 checks)

Co-Authored-By: Claude Opus 4.6 <noreply@anthropic.com>
</commit_message>
<xml_diff>
--- a/maven_training/MSS_PROGRAM_OVERVIEW.pptx
+++ b/maven_training/MSS_PROGRAM_OVERVIEW.pptx
@@ -4800,8 +4800,8 @@
         </p:nvSpPr>
         <p:spPr>
           <a:xfrm>
-            <a:off x="4315968" y="5513832"/>
-            <a:ext cx="3602736" cy="274320"/>
+            <a:off x="4315968" y="5458968"/>
+            <a:ext cx="3602736" cy="164592"/>
           </a:xfrm>
           <a:prstGeom prst="rect">
             <a:avLst/>
@@ -4816,7 +4816,7 @@
           <a:p>
             <a:pPr algn="l"/>
             <a:r>
-              <a:rPr sz="1000" b="0" i="0">
+              <a:rPr sz="800" b="0" i="0">
                 <a:solidFill>
                   <a:srgbClr val="1A1A1A"/>
                 </a:solidFill>
@@ -4834,8 +4834,8 @@
         </p:nvSpPr>
         <p:spPr>
           <a:xfrm>
-            <a:off x="4315968" y="5797296"/>
-            <a:ext cx="3602736" cy="274320"/>
+            <a:off x="4315968" y="5600700"/>
+            <a:ext cx="3602736" cy="164592"/>
           </a:xfrm>
           <a:prstGeom prst="rect">
             <a:avLst/>
@@ -4850,12 +4850,12 @@
           <a:p>
             <a:pPr algn="l"/>
             <a:r>
-              <a:rPr sz="1000" b="0" i="0">
+              <a:rPr sz="800" b="0" i="0">
                 <a:solidFill>
                   <a:srgbClr val="1A1A1A"/>
                 </a:solidFill>
               </a:rPr>
-              <a:t>▪  ~141 published PDFs; Markdown source maintained in version control</a:t>
+              <a:t>▪  160+ published PDFs; Markdown source in version control</a:t>
             </a:r>
           </a:p>
         </p:txBody>
@@ -4868,8 +4868,8 @@
         </p:nvSpPr>
         <p:spPr>
           <a:xfrm>
-            <a:off x="4315968" y="6080760"/>
-            <a:ext cx="3602736" cy="274320"/>
+            <a:off x="4315968" y="5742432"/>
+            <a:ext cx="3602736" cy="164592"/>
           </a:xfrm>
           <a:prstGeom prst="rect">
             <a:avLst/>
@@ -4884,7 +4884,7 @@
           <a:p>
             <a:pPr algn="l"/>
             <a:r>
-              <a:rPr sz="1000" b="0" i="0">
+              <a:rPr sz="800" b="0" i="0">
                 <a:solidFill>
                   <a:srgbClr val="1A1A1A"/>
                 </a:solidFill>
@@ -4902,8 +4902,8 @@
         </p:nvSpPr>
         <p:spPr>
           <a:xfrm>
-            <a:off x="4315968" y="6364224"/>
-            <a:ext cx="3602736" cy="274320"/>
+            <a:off x="4315968" y="5884164"/>
+            <a:ext cx="3602736" cy="164592"/>
           </a:xfrm>
           <a:prstGeom prst="rect">
             <a:avLst/>
@@ -4918,7 +4918,7 @@
           <a:p>
             <a:pPr algn="l"/>
             <a:r>
-              <a:rPr sz="1000" b="0" i="0">
+              <a:rPr sz="800" b="0" i="0">
                 <a:solidFill>
                   <a:srgbClr val="1A1A1A"/>
                 </a:solidFill>
@@ -4936,8 +4936,8 @@
         </p:nvSpPr>
         <p:spPr>
           <a:xfrm>
-            <a:off x="4315968" y="6647688"/>
-            <a:ext cx="3602736" cy="274320"/>
+            <a:off x="4315968" y="6025896"/>
+            <a:ext cx="3602736" cy="164592"/>
           </a:xfrm>
           <a:prstGeom prst="rect">
             <a:avLst/>
@@ -4952,12 +4952,12 @@
           <a:p>
             <a:pPr algn="l"/>
             <a:r>
-              <a:rPr sz="1000" b="0" i="0">
+              <a:rPr sz="800" b="0" i="0">
                 <a:solidFill>
                   <a:srgbClr val="1A1A1A"/>
                 </a:solidFill>
               </a:rPr>
-              <a:t>▪  Authority: USAREUR-AF G6/G9 Data Governance Directive (MSS-POI-001)</a:t>
+              <a:t>▪  Authority: C2DAO Data Governance Directive (MSS-POI-001)</a:t>
             </a:r>
           </a:p>
         </p:txBody>
@@ -4970,8 +4970,8 @@
         </p:nvSpPr>
         <p:spPr>
           <a:xfrm>
-            <a:off x="4315968" y="6931152"/>
-            <a:ext cx="3602736" cy="274320"/>
+            <a:off x="4315968" y="6167628"/>
+            <a:ext cx="3602736" cy="164592"/>
           </a:xfrm>
           <a:prstGeom prst="rect">
             <a:avLst/>
@@ -4986,7 +4986,7 @@
           <a:p>
             <a:pPr algn="l"/>
             <a:r>
-              <a:rPr sz="1000" b="0" i="0">
+              <a:rPr sz="800" b="0" i="0">
                 <a:solidFill>
                   <a:srgbClr val="1A1A1A"/>
                 </a:solidFill>
@@ -6273,7 +6273,7 @@
         <p:spPr>
           <a:xfrm>
             <a:off x="228600" y="6519672"/>
-            <a:ext cx="2286000" cy="292608"/>
+            <a:ext cx="1645920" cy="292608"/>
           </a:xfrm>
           <a:prstGeom prst="rect">
             <a:avLst/>
@@ -6306,8 +6306,8 @@
         </p:nvSpPr>
         <p:spPr>
           <a:xfrm>
-            <a:off x="0" y="6519672"/>
-            <a:ext cx="12188952" cy="292608"/>
+            <a:off x="2011680" y="6519672"/>
+            <a:ext cx="5577840" cy="292608"/>
           </a:xfrm>
           <a:prstGeom prst="rect">
             <a:avLst/>
@@ -6340,8 +6340,8 @@
         </p:nvSpPr>
         <p:spPr>
           <a:xfrm>
-            <a:off x="7159752" y="6519672"/>
-            <a:ext cx="4846320" cy="292608"/>
+            <a:off x="7799832" y="6519672"/>
+            <a:ext cx="4206240" cy="292608"/>
           </a:xfrm>
           <a:prstGeom prst="rect">
             <a:avLst/>
@@ -6356,12 +6356,12 @@
           <a:p>
             <a:pPr algn="r"/>
             <a:r>
-              <a:rPr sz="800" b="0" i="1">
+              <a:rPr sz="700" b="0" i="1">
                 <a:solidFill>
                   <a:srgbClr val="C8B560"/>
                 </a:solidFill>
               </a:rPr>
-              <a:t>For official use — distribution authorized to U.S. Government agencies and contractors only</a:t>
+              <a:t>Distribution: U.S. Government agencies and contractors</a:t>
             </a:r>
           </a:p>
         </p:txBody>

</xml_diff>